<commit_message>
Repair generated PowerPoint packages
Co-authored-by: Copilot <223556219+Copilot@users.noreply.github.com>
</commit_message>
<xml_diff>
--- a/decks/token-optimization-context-engineering.executive.pptx
+++ b/decks/token-optimization-context-engineering.executive.pptx
@@ -30,7 +30,7 @@
     <p:sldId id="278" r:id="rId30"/>
     <p:sldId id="279" r:id="rId31"/>
   </p:sldIdLst>
-  <p:sldSz cx="12191695" cy="6858000" type="screen4x3"/>
+  <p:sldSz cx="12191695" cy="6858000" type="screen16x9"/>
   <p:notesSz cx="6858000" cy="9144000"/>
   <p:defaultTextStyle>
     <a:defPPr>
@@ -9192,8 +9192,8 @@
         </p:nvSpPr>
         <p:spPr>
           <a:xfrm>
-            <a:off x="4480560" y="5303520"/>
-            <a:ext cx="3383280" cy="658368"/>
+            <a:off x="4480560" y="5166360"/>
+            <a:ext cx="3383280" cy="841248"/>
           </a:xfrm>
           <a:prstGeom prst="roundRect">
             <a:avLst/>
@@ -9237,7 +9237,7 @@
         </p:nvSpPr>
         <p:spPr>
           <a:xfrm>
-            <a:off x="4681728" y="5458968"/>
+            <a:off x="4681728" y="5321808"/>
             <a:ext cx="2980944" cy="329184"/>
           </a:xfrm>
           <a:prstGeom prst="rect">
@@ -9273,8 +9273,8 @@
         </p:nvSpPr>
         <p:spPr>
           <a:xfrm>
-            <a:off x="4645152" y="5870448"/>
-            <a:ext cx="3054096" cy="-18288"/>
+            <a:off x="4645152" y="5733288"/>
+            <a:ext cx="3054096" cy="164592"/>
           </a:xfrm>
           <a:prstGeom prst="rect">
             <a:avLst/>
@@ -13648,8 +13648,8 @@
         </p:nvSpPr>
         <p:spPr>
           <a:xfrm>
-            <a:off x="713232" y="5486400"/>
-            <a:ext cx="10652760" cy="438912"/>
+            <a:off x="713232" y="5413248"/>
+            <a:ext cx="10652760" cy="713232"/>
           </a:xfrm>
           <a:prstGeom prst="roundRect">
             <a:avLst/>
@@ -13693,7 +13693,7 @@
         </p:nvSpPr>
         <p:spPr>
           <a:xfrm>
-            <a:off x="914400" y="5641848"/>
+            <a:off x="914400" y="5568696"/>
             <a:ext cx="10250424" cy="329184"/>
           </a:xfrm>
           <a:prstGeom prst="rect">
@@ -13716,7 +13716,7 @@
               </a:defRPr>
             </a:pPr>
             <a:r>
-              <a:t>Output</a:t>
+              <a:t>Output: a smaller, safer context plan students can reuse after the workshop.</a:t>
             </a:r>
           </a:p>
         </p:txBody>
@@ -13724,45 +13724,6 @@
       <p:sp>
         <p:nvSpPr>
           <p:cNvPr id="20" name="TextBox 19"/>
-          <p:cNvSpPr txBox="1"/>
-          <p:nvPr/>
-        </p:nvSpPr>
-        <p:spPr>
-          <a:xfrm>
-            <a:off x="877824" y="6053328"/>
-            <a:ext cx="10323576" cy="-237744"/>
-          </a:xfrm>
-          <a:prstGeom prst="rect">
-            <a:avLst/>
-          </a:prstGeom>
-          <a:noFill/>
-        </p:spPr>
-        <p:txBody>
-          <a:bodyPr wrap="square" lIns="164592" rIns="146304" tIns="109728" bIns="91440">
-            <a:spAutoFit/>
-          </a:bodyPr>
-          <a:lstStyle/>
-          <a:p>
-            <a:pPr>
-              <a:spcAft>
-                <a:spcPts val="700"/>
-              </a:spcAft>
-              <a:defRPr sz="1100">
-                <a:solidFill>
-                  <a:srgbClr val="C9D1D9"/>
-                </a:solidFill>
-                <a:latin typeface="Aptos"/>
-              </a:defRPr>
-            </a:pPr>
-            <a:r>
-              <a:t>A smaller, safer context plan students can reuse after the workshop.</a:t>
-            </a:r>
-          </a:p>
-        </p:txBody>
-      </p:sp>
-      <p:sp>
-        <p:nvSpPr>
-          <p:cNvPr id="21" name="TextBox 20"/>
           <p:cNvSpPr txBox="1"/>
           <p:nvPr/>
         </p:nvSpPr>
@@ -13798,7 +13759,7 @@
       </p:sp>
       <p:sp>
         <p:nvSpPr>
-          <p:cNvPr id="22" name="Rectangle 21"/>
+          <p:cNvPr id="21" name="Rectangle 20"/>
           <p:cNvSpPr/>
           <p:nvPr/>
         </p:nvSpPr>
@@ -13843,7 +13804,7 @@
       </p:sp>
       <p:sp>
         <p:nvSpPr>
-          <p:cNvPr id="23" name="Rectangle 22"/>
+          <p:cNvPr id="22" name="Rectangle 21"/>
           <p:cNvSpPr/>
           <p:nvPr/>
         </p:nvSpPr>
@@ -15262,8 +15223,8 @@
         </p:nvSpPr>
         <p:spPr>
           <a:xfrm>
-            <a:off x="713232" y="5486400"/>
-            <a:ext cx="10652760" cy="438912"/>
+            <a:off x="713232" y="5413248"/>
+            <a:ext cx="10652760" cy="713232"/>
           </a:xfrm>
           <a:prstGeom prst="roundRect">
             <a:avLst/>
@@ -15307,7 +15268,7 @@
         </p:nvSpPr>
         <p:spPr>
           <a:xfrm>
-            <a:off x="914400" y="5641848"/>
+            <a:off x="914400" y="5568696"/>
             <a:ext cx="10250424" cy="329184"/>
           </a:xfrm>
           <a:prstGeom prst="rect">
@@ -15330,7 +15291,7 @@
               </a:defRPr>
             </a:pPr>
             <a:r>
-              <a:t>Output</a:t>
+              <a:t>Output: a smaller, safer context plan students can reuse after the workshop.</a:t>
             </a:r>
           </a:p>
         </p:txBody>
@@ -15338,45 +15299,6 @@
       <p:sp>
         <p:nvSpPr>
           <p:cNvPr id="24" name="TextBox 23"/>
-          <p:cNvSpPr txBox="1"/>
-          <p:nvPr/>
-        </p:nvSpPr>
-        <p:spPr>
-          <a:xfrm>
-            <a:off x="877824" y="6053328"/>
-            <a:ext cx="10323576" cy="-237744"/>
-          </a:xfrm>
-          <a:prstGeom prst="rect">
-            <a:avLst/>
-          </a:prstGeom>
-          <a:noFill/>
-        </p:spPr>
-        <p:txBody>
-          <a:bodyPr wrap="square" lIns="164592" rIns="146304" tIns="109728" bIns="91440">
-            <a:spAutoFit/>
-          </a:bodyPr>
-          <a:lstStyle/>
-          <a:p>
-            <a:pPr>
-              <a:spcAft>
-                <a:spcPts val="700"/>
-              </a:spcAft>
-              <a:defRPr sz="1100">
-                <a:solidFill>
-                  <a:srgbClr val="C9D1D9"/>
-                </a:solidFill>
-                <a:latin typeface="Aptos"/>
-              </a:defRPr>
-            </a:pPr>
-            <a:r>
-              <a:t>A smaller, safer context plan students can reuse after the workshop.</a:t>
-            </a:r>
-          </a:p>
-        </p:txBody>
-      </p:sp>
-      <p:sp>
-        <p:nvSpPr>
-          <p:cNvPr id="25" name="TextBox 24"/>
           <p:cNvSpPr txBox="1"/>
           <p:nvPr/>
         </p:nvSpPr>
@@ -15412,7 +15334,7 @@
       </p:sp>
       <p:sp>
         <p:nvSpPr>
-          <p:cNvPr id="26" name="Rectangle 25"/>
+          <p:cNvPr id="25" name="Rectangle 24"/>
           <p:cNvSpPr/>
           <p:nvPr/>
         </p:nvSpPr>
@@ -15457,7 +15379,7 @@
       </p:sp>
       <p:sp>
         <p:nvSpPr>
-          <p:cNvPr id="27" name="Rectangle 26"/>
+          <p:cNvPr id="26" name="Rectangle 25"/>
           <p:cNvSpPr/>
           <p:nvPr/>
         </p:nvSpPr>
@@ -17611,45 +17533,6 @@
         </p:nvSpPr>
         <p:spPr>
           <a:xfrm>
-            <a:off x="2359152" y="5596128"/>
-            <a:ext cx="7260336" cy="54864"/>
-          </a:xfrm>
-          <a:prstGeom prst="rect">
-            <a:avLst/>
-          </a:prstGeom>
-          <a:noFill/>
-        </p:spPr>
-        <p:txBody>
-          <a:bodyPr wrap="square" lIns="164592" rIns="146304" tIns="109728" bIns="91440">
-            <a:spAutoFit/>
-          </a:bodyPr>
-          <a:lstStyle/>
-          <a:p>
-            <a:pPr>
-              <a:spcAft>
-                <a:spcPts val="700"/>
-              </a:spcAft>
-              <a:defRPr sz="1200">
-                <a:solidFill>
-                  <a:srgbClr val="C9D1D9"/>
-                </a:solidFill>
-                <a:latin typeface="Aptos"/>
-              </a:defRPr>
-            </a:pPr>
-            <a:r>
-              <a:t>Use baselines, then compare retries, review quality, rework, and usage.</a:t>
-            </a:r>
-          </a:p>
-        </p:txBody>
-      </p:sp>
-      <p:sp>
-        <p:nvSpPr>
-          <p:cNvPr id="18" name="TextBox 17"/>
-          <p:cNvSpPr txBox="1"/>
-          <p:nvPr/>
-        </p:nvSpPr>
-        <p:spPr>
-          <a:xfrm>
             <a:off x="594360" y="6364224"/>
             <a:ext cx="6583680" cy="256032"/>
           </a:xfrm>
@@ -17680,7 +17563,7 @@
       </p:sp>
       <p:sp>
         <p:nvSpPr>
-          <p:cNvPr id="19" name="Rectangle 18"/>
+          <p:cNvPr id="18" name="Rectangle 17"/>
           <p:cNvSpPr/>
           <p:nvPr/>
         </p:nvSpPr>
@@ -17725,7 +17608,7 @@
       </p:sp>
       <p:sp>
         <p:nvSpPr>
-          <p:cNvPr id="20" name="Rectangle 19"/>
+          <p:cNvPr id="19" name="Rectangle 18"/>
           <p:cNvSpPr/>
           <p:nvPr/>
         </p:nvSpPr>

</xml_diff>